<commit_message>
feat: use exponential decay model for projections
Replace linear regression with physically-motivated exponential decay:
floor + (S0 - floor) * exp(-r * t)

Floor = 60 days (core winter retains snow even with warming).
Produces realistic curves that flatten toward a minimum rather than
declining linearly to zero.

Low Alps 2050: Current=97 days, RCP 8.5=60 days, RCP 2.6=121 days.
</commit_message>
<xml_diff>
--- a/AIB_03_00_SLIDES_ASU.pptx
+++ b/AIB_03_00_SLIDES_ASU.pptx
@@ -1746,82 +1746,82 @@
                   <c:v>108</c:v>
                 </c:pt>
                 <c:pt idx="25">
-                  <c:v>106.2</c:v>
+                  <c:v>123.9</c:v>
                 </c:pt>
                 <c:pt idx="26">
-                  <c:v>104.1</c:v>
+                  <c:v>121.5</c:v>
                 </c:pt>
                 <c:pt idx="27">
-                  <c:v>102</c:v>
+                  <c:v>119.2</c:v>
                 </c:pt>
                 <c:pt idx="28">
-                  <c:v>99.8</c:v>
+                  <c:v>117</c:v>
                 </c:pt>
                 <c:pt idx="29">
-                  <c:v>97.7</c:v>
+                  <c:v>114.9</c:v>
                 </c:pt>
                 <c:pt idx="30">
-                  <c:v>95.6</c:v>
+                  <c:v>112.8</c:v>
                 </c:pt>
                 <c:pt idx="31">
-                  <c:v>93.5</c:v>
+                  <c:v>110.8</c:v>
                 </c:pt>
                 <c:pt idx="32">
-                  <c:v>91.4</c:v>
+                  <c:v>108.9</c:v>
                 </c:pt>
                 <c:pt idx="33">
-                  <c:v>89.3</c:v>
+                  <c:v>107.1</c:v>
                 </c:pt>
                 <c:pt idx="34">
-                  <c:v>87.1</c:v>
+                  <c:v>105.3</c:v>
                 </c:pt>
                 <c:pt idx="35">
-                  <c:v>85</c:v>
+                  <c:v>111.1</c:v>
                 </c:pt>
                 <c:pt idx="36">
-                  <c:v>82.9</c:v>
+                  <c:v>103.6</c:v>
                 </c:pt>
                 <c:pt idx="37">
-                  <c:v>80.8</c:v>
+                  <c:v>101.9</c:v>
                 </c:pt>
                 <c:pt idx="38">
-                  <c:v>78.7</c:v>
+                  <c:v>100.3</c:v>
                 </c:pt>
                 <c:pt idx="39">
-                  <c:v>76.5</c:v>
+                  <c:v>98.8</c:v>
                 </c:pt>
                 <c:pt idx="40">
-                  <c:v>74.4</c:v>
+                  <c:v>97.3</c:v>
                 </c:pt>
                 <c:pt idx="41">
-                  <c:v>72.3</c:v>
+                  <c:v>96.6</c:v>
                 </c:pt>
                 <c:pt idx="42">
-                  <c:v>70.2</c:v>
+                  <c:v>96</c:v>
                 </c:pt>
                 <c:pt idx="43">
-                  <c:v>68.1</c:v>
+                  <c:v>95.5</c:v>
                 </c:pt>
                 <c:pt idx="44">
-                  <c:v>66</c:v>
+                  <c:v>95</c:v>
                 </c:pt>
                 <c:pt idx="45">
-                  <c:v>63.8</c:v>
+                  <c:v>94.5</c:v>
                 </c:pt>
                 <c:pt idx="46">
-                  <c:v>61.7</c:v>
+                  <c:v>94</c:v>
                 </c:pt>
                 <c:pt idx="47">
-                  <c:v>59.6</c:v>
+                  <c:v>93.6</c:v>
                 </c:pt>
                 <c:pt idx="48">
-                  <c:v>57.5</c:v>
+                  <c:v>93.2</c:v>
                 </c:pt>
                 <c:pt idx="49">
-                  <c:v>55.4</c:v>
+                  <c:v>92.8</c:v>
                 </c:pt>
                 <c:pt idx="50">
-                  <c:v>53.5</c:v>
+                  <c:v>96.6</c:v>
                 </c:pt>
               </c:numCache>
             </c:numRef>
@@ -2142,82 +2142,82 @@
                   <c:v>108</c:v>
                 </c:pt>
                 <c:pt idx="25">
-                  <c:v>104.8</c:v>
+                  <c:v>94.9</c:v>
                 </c:pt>
                 <c:pt idx="26">
-                  <c:v>101.7</c:v>
+                  <c:v>90.5</c:v>
                 </c:pt>
                 <c:pt idx="27">
-                  <c:v>98.5</c:v>
+                  <c:v>86.5</c:v>
                 </c:pt>
                 <c:pt idx="28">
-                  <c:v>95.3</c:v>
+                  <c:v>82.8</c:v>
                 </c:pt>
                 <c:pt idx="29">
-                  <c:v>92.2</c:v>
+                  <c:v>79.4</c:v>
                 </c:pt>
                 <c:pt idx="30">
-                  <c:v>89</c:v>
+                  <c:v>76.3</c:v>
                 </c:pt>
                 <c:pt idx="31">
-                  <c:v>85.8</c:v>
+                  <c:v>73.5</c:v>
                 </c:pt>
                 <c:pt idx="32">
-                  <c:v>82.7</c:v>
+                  <c:v>71</c:v>
                 </c:pt>
                 <c:pt idx="33">
-                  <c:v>79.5</c:v>
+                  <c:v>68.7</c:v>
                 </c:pt>
                 <c:pt idx="34">
-                  <c:v>76.3</c:v>
+                  <c:v>66.6</c:v>
                 </c:pt>
                 <c:pt idx="35">
-                  <c:v>73.2</c:v>
+                  <c:v>77.5</c:v>
                 </c:pt>
                 <c:pt idx="36">
-                  <c:v>70</c:v>
+                  <c:v>64.8</c:v>
                 </c:pt>
                 <c:pt idx="37">
-                  <c:v>66.8</c:v>
+                  <c:v>63.2</c:v>
                 </c:pt>
                 <c:pt idx="38">
-                  <c:v>63.7</c:v>
+                  <c:v>61.8</c:v>
                 </c:pt>
                 <c:pt idx="39">
-                  <c:v>60.5</c:v>
+                  <c:v>60.6</c:v>
                 </c:pt>
                 <c:pt idx="40">
-                  <c:v>57.3</c:v>
+                  <c:v>59.5</c:v>
                 </c:pt>
                 <c:pt idx="41">
-                  <c:v>54.2</c:v>
+                  <c:v>59.3</c:v>
                 </c:pt>
                 <c:pt idx="42">
-                  <c:v>51</c:v>
+                  <c:v>59.1</c:v>
                 </c:pt>
                 <c:pt idx="43">
-                  <c:v>47.8</c:v>
+                  <c:v>58.9</c:v>
                 </c:pt>
                 <c:pt idx="44">
-                  <c:v>44.7</c:v>
+                  <c:v>58.8</c:v>
                 </c:pt>
                 <c:pt idx="45">
-                  <c:v>41.5</c:v>
+                  <c:v>58.7</c:v>
                 </c:pt>
                 <c:pt idx="46">
-                  <c:v>38.3</c:v>
+                  <c:v>58.6</c:v>
                 </c:pt>
                 <c:pt idx="47">
-                  <c:v>35.2</c:v>
+                  <c:v>58.5</c:v>
                 </c:pt>
                 <c:pt idx="48">
-                  <c:v>32</c:v>
+                  <c:v>58.5</c:v>
                 </c:pt>
                 <c:pt idx="49">
-                  <c:v>28.8</c:v>
+                  <c:v>58.4</c:v>
                 </c:pt>
                 <c:pt idx="50">
-                  <c:v>26.1</c:v>
+                  <c:v>59.7</c:v>
                 </c:pt>
               </c:numCache>
             </c:numRef>
@@ -2538,82 +2538,82 @@
                   <c:v>108</c:v>
                 </c:pt>
                 <c:pt idx="25">
-                  <c:v>106.7</c:v>
+                  <c:v>141.3</c:v>
                 </c:pt>
                 <c:pt idx="26">
-                  <c:v>105.5</c:v>
+                  <c:v>139.5</c:v>
                 </c:pt>
                 <c:pt idx="27">
-                  <c:v>104.2</c:v>
+                  <c:v>137.8</c:v>
                 </c:pt>
                 <c:pt idx="28">
-                  <c:v>103</c:v>
+                  <c:v>136.2</c:v>
                 </c:pt>
                 <c:pt idx="29">
-                  <c:v>101.7</c:v>
+                  <c:v>134.6</c:v>
                 </c:pt>
                 <c:pt idx="30">
-                  <c:v>100.4</c:v>
+                  <c:v>133.1</c:v>
                 </c:pt>
                 <c:pt idx="31">
-                  <c:v>99.2</c:v>
+                  <c:v>131.7</c:v>
                 </c:pt>
                 <c:pt idx="32">
-                  <c:v>97.9</c:v>
+                  <c:v>130.4</c:v>
                 </c:pt>
                 <c:pt idx="33">
-                  <c:v>96.7</c:v>
+                  <c:v>129.1</c:v>
                 </c:pt>
                 <c:pt idx="34">
-                  <c:v>95.4</c:v>
+                  <c:v>127.9</c:v>
                 </c:pt>
                 <c:pt idx="35">
-                  <c:v>94.2</c:v>
+                  <c:v>132.2</c:v>
                 </c:pt>
                 <c:pt idx="36">
-                  <c:v>92.9</c:v>
+                  <c:v>126.7</c:v>
                 </c:pt>
                 <c:pt idx="37">
-                  <c:v>91.6</c:v>
+                  <c:v>125.6</c:v>
                 </c:pt>
                 <c:pt idx="38">
-                  <c:v>90.4</c:v>
+                  <c:v>124.6</c:v>
                 </c:pt>
                 <c:pt idx="39">
-                  <c:v>89.1</c:v>
+                  <c:v>123.6</c:v>
                 </c:pt>
                 <c:pt idx="40">
-                  <c:v>87.9</c:v>
+                  <c:v>122.7</c:v>
                 </c:pt>
                 <c:pt idx="41">
-                  <c:v>86.6</c:v>
+                  <c:v>122.4</c:v>
                 </c:pt>
                 <c:pt idx="42">
-                  <c:v>85.4</c:v>
+                  <c:v>122.1</c:v>
                 </c:pt>
                 <c:pt idx="43">
-                  <c:v>84.1</c:v>
+                  <c:v>121.8</c:v>
                 </c:pt>
                 <c:pt idx="44">
-                  <c:v>82.8</c:v>
+                  <c:v>121.5</c:v>
                 </c:pt>
                 <c:pt idx="45">
-                  <c:v>81.6</c:v>
+                  <c:v>121.3</c:v>
                 </c:pt>
                 <c:pt idx="46">
-                  <c:v>80.3</c:v>
+                  <c:v>121.1</c:v>
                 </c:pt>
                 <c:pt idx="47">
-                  <c:v>79.1</c:v>
+                  <c:v>120.9</c:v>
                 </c:pt>
                 <c:pt idx="48">
-                  <c:v>77.8</c:v>
+                  <c:v>120.8</c:v>
                 </c:pt>
                 <c:pt idx="49">
-                  <c:v>76.6</c:v>
+                  <c:v>120.6</c:v>
                 </c:pt>
                 <c:pt idx="50">
-                  <c:v>75.4</c:v>
+                  <c:v>120.9</c:v>
                 </c:pt>
               </c:numCache>
             </c:numRef>
@@ -6144,7 +6144,7 @@
                 <a:ea typeface="Calibri" pitchFamily="34" charset="-122"/>
                 <a:cs typeface="Calibri" pitchFamily="34" charset="-120"/>
               </a:rPr>
-              <a:t>Alpine snowmelt feeds the Rhine, Danube, Po, and Rhone rivers. Projections show low-elevation snow dropping to just 54 days by 2050, threatening hydropower, agriculture, and municipal water.</a:t>
+              <a:t>Alpine snowmelt feeds the Rhine, Danube, Po, and Rhone rivers. Projections show low-elevation snow dropping to ~97 days by 2050 (60 under RCP 8.5), threatening hydropower, agriculture, and municipal water.</a:t>
             </a:r>
             <a:endParaRPr lang="en-US" sz="1300" dirty="0"/>
           </a:p>
@@ -6253,7 +6253,7 @@
                 <a:ea typeface="Calibri" pitchFamily="34" charset="-122"/>
                 <a:cs typeface="Calibri" pitchFamily="34" charset="-120"/>
               </a:rPr>
-              <a:t>Low-elevation resorts (&lt;1500m) face under 2 months of viable snow by 2050 (54 days). This helps the 70B+ euro European ski industry make data-driven decisions about snowmaking and diversification.</a:t>
+              <a:t>Low-elevation resorts (&lt;1500m) face ~3 months of snow by 2050 (97 days current, 60 under RCP 8.5). This helps the 70B+ euro ski industry make data-driven decisions about snowmaking and diversification.</a:t>
             </a:r>
             <a:endParaRPr lang="en-US" sz="1300" dirty="0"/>
           </a:p>
@@ -10479,7 +10479,7 @@
                 <a:ea typeface="Georgia" pitchFamily="34" charset="-122"/>
                 <a:cs typeface="Georgia" pitchFamily="34" charset="-120"/>
               </a:rPr>
-              <a:t>54</a:t>
+              <a:t>97</a:t>
             </a:r>
             <a:endParaRPr lang="en-US" sz="5200" dirty="0"/>
           </a:p>
@@ -13370,7 +13370,7 @@
                           <a:ea typeface="Calibri" pitchFamily="34" charset="-122"/>
                           <a:cs typeface="Calibri" pitchFamily="34" charset="-120"/>
                         </a:rPr>
-                        <a:t>54 days</a:t>
+                        <a:t>97 days</a:t>
                       </a:r>
                       <a:endParaRPr lang="en-US" sz="1000" dirty="0">
                         <a:latin typeface="Calibri" charset="0"/>
@@ -13438,7 +13438,7 @@
                           <a:ea typeface="Calibri" pitchFamily="34" charset="-122"/>
                           <a:cs typeface="Calibri" pitchFamily="34" charset="-120"/>
                         </a:rPr>
-                        <a:t>-55 days</a:t>
+                        <a:t>-11 days</a:t>
                       </a:r>
                       <a:endParaRPr lang="en-US" sz="1000" dirty="0">
                         <a:latin typeface="Calibri" charset="0"/>
@@ -13576,7 +13576,7 @@
                           <a:ea typeface="Calibri" pitchFamily="34" charset="-122"/>
                           <a:cs typeface="Calibri" pitchFamily="34" charset="-120"/>
                         </a:rPr>
-                        <a:t>26 days</a:t>
+                        <a:t>60 days</a:t>
                       </a:r>
                       <a:endParaRPr lang="en-US" sz="1000" dirty="0">
                         <a:latin typeface="Calibri" charset="0"/>
@@ -13644,7 +13644,7 @@
                           <a:ea typeface="Calibri" pitchFamily="34" charset="-122"/>
                           <a:cs typeface="Calibri" pitchFamily="34" charset="-120"/>
                         </a:rPr>
-                        <a:t>-82 days</a:t>
+                        <a:t>-48 days</a:t>
                       </a:r>
                       <a:endParaRPr lang="en-US" sz="1000" dirty="0">
                         <a:latin typeface="Calibri" charset="0"/>
@@ -13782,7 +13782,7 @@
                           <a:ea typeface="Calibri" pitchFamily="34" charset="-122"/>
                           <a:cs typeface="Calibri" pitchFamily="34" charset="-120"/>
                         </a:rPr>
-                        <a:t>75 days</a:t>
+                        <a:t>121 days</a:t>
                       </a:r>
                       <a:endParaRPr lang="en-US" sz="1000" dirty="0">
                         <a:latin typeface="Calibri" charset="0"/>
@@ -13850,7 +13850,7 @@
                           <a:ea typeface="Calibri" pitchFamily="34" charset="-122"/>
                           <a:cs typeface="Calibri" pitchFamily="34" charset="-120"/>
                         </a:rPr>
-                        <a:t>-33 days</a:t>
+                        <a:t>-13 days</a:t>
                       </a:r>
                       <a:endParaRPr lang="en-US" sz="1000" dirty="0">
                         <a:latin typeface="Calibri" charset="0"/>
@@ -13942,7 +13942,7 @@
                 <a:ea typeface="Calibri" pitchFamily="34" charset="-122"/>
                 <a:cs typeface="Calibri" pitchFamily="34" charset="-120"/>
               </a:rPr>
-              <a:t>Under current trends, low-elevation Alps will have just 54 snow days by 2050 — under 2 months. RCP 8.5 drops it to 26 days.</a:t>
+              <a:t>Under current trends, low-elevation Alps will have ~97 snow days by 2050 (just 3 months). RCP 8.5 drops it to 60 days — 2 months.</a:t>
             </a:r>
             <a:endParaRPr lang="en-US" sz="1100" dirty="0"/>
           </a:p>
@@ -13962,7 +13962,7 @@
                 <a:ea typeface="Calibri" pitchFamily="34" charset="-122"/>
                 <a:cs typeface="Calibri" pitchFamily="34" charset="-120"/>
               </a:rPr>
-              <a:t>Mid Alps remain stable at ~346 days. High Alps stay at 366 (year-round). The divergence between elevation bands will only widen.</a:t>
+              <a:t>Mid Alps remain stable at ~311 days. High Alps stay at 366 (year-round). The divergence between elevation bands will only widen.</a:t>
             </a:r>
             <a:endParaRPr lang="en-US" sz="1100" dirty="0"/>
           </a:p>
@@ -14000,7 +14000,7 @@
                 <a:ea typeface="Calibri" pitchFamily="34" charset="-122"/>
                 <a:cs typeface="Calibri" pitchFamily="34" charset="-120"/>
               </a:rPr>
-              <a:t>Linear regression projection on 25-year ERA5 data. RCP scenarios apply IPCC-based multipliers to the observed decline rate (-2.11 days/year).</a:t>
+              <a:t>Exponential decay model: floor + (S0-floor)*exp(-r*t). Floor = 60 days (core winter retains snow). Physically motivated — decline slows as it approaches the climatological minimum.</a:t>
             </a:r>
             <a:endParaRPr lang="en-US" sz="1100" dirty="0"/>
           </a:p>

</xml_diff>

<commit_message>
update: slides and app reflect exponential decay projections
Low Alps: 108 -> 76 days (current), 57 (RCP 8.5), 88 (RCP 2.6)
Method: exponential decay calibrated to observed slope with physical floor
Updated all references in slides, impact section, and app label
</commit_message>
<xml_diff>
--- a/AIB_03_00_SLIDES_ASU.pptx
+++ b/AIB_03_00_SLIDES_ASU.pptx
@@ -1746,82 +1746,82 @@
                   <c:v>108</c:v>
                 </c:pt>
                 <c:pt idx="25">
-                  <c:v>123.9</c:v>
+                  <c:v>106.2</c:v>
                 </c:pt>
                 <c:pt idx="26">
-                  <c:v>121.5</c:v>
+                  <c:v>104.3</c:v>
                 </c:pt>
                 <c:pt idx="27">
-                  <c:v>119.2</c:v>
+                  <c:v>102.4</c:v>
                 </c:pt>
                 <c:pt idx="28">
-                  <c:v>117</c:v>
+                  <c:v>100.6</c:v>
                 </c:pt>
                 <c:pt idx="29">
-                  <c:v>114.9</c:v>
+                  <c:v>98.8</c:v>
                 </c:pt>
                 <c:pt idx="30">
-                  <c:v>112.8</c:v>
+                  <c:v>97.2</c:v>
                 </c:pt>
                 <c:pt idx="31">
-                  <c:v>110.8</c:v>
+                  <c:v>95.6</c:v>
                 </c:pt>
                 <c:pt idx="32">
-                  <c:v>108.9</c:v>
+                  <c:v>94.1</c:v>
                 </c:pt>
                 <c:pt idx="33">
-                  <c:v>107.1</c:v>
+                  <c:v>92.6</c:v>
                 </c:pt>
                 <c:pt idx="34">
-                  <c:v>105.3</c:v>
+                  <c:v>91.2</c:v>
                 </c:pt>
                 <c:pt idx="35">
-                  <c:v>111.1</c:v>
+                  <c:v>89.9</c:v>
                 </c:pt>
                 <c:pt idx="36">
-                  <c:v>103.6</c:v>
+                  <c:v>88.6</c:v>
                 </c:pt>
                 <c:pt idx="37">
-                  <c:v>101.9</c:v>
+                  <c:v>87.4</c:v>
                 </c:pt>
                 <c:pt idx="38">
-                  <c:v>100.3</c:v>
+                  <c:v>86.2</c:v>
                 </c:pt>
                 <c:pt idx="39">
-                  <c:v>98.8</c:v>
+                  <c:v>85.1</c:v>
                 </c:pt>
                 <c:pt idx="40">
-                  <c:v>97.3</c:v>
+                  <c:v>84</c:v>
                 </c:pt>
                 <c:pt idx="41">
-                  <c:v>96.6</c:v>
+                  <c:v>83</c:v>
                 </c:pt>
                 <c:pt idx="42">
-                  <c:v>96</c:v>
+                  <c:v>82</c:v>
                 </c:pt>
                 <c:pt idx="43">
-                  <c:v>95.5</c:v>
+                  <c:v>81.1</c:v>
                 </c:pt>
                 <c:pt idx="44">
-                  <c:v>95</c:v>
+                  <c:v>80.2</c:v>
                 </c:pt>
                 <c:pt idx="45">
-                  <c:v>94.5</c:v>
+                  <c:v>79.3</c:v>
                 </c:pt>
                 <c:pt idx="46">
-                  <c:v>94</c:v>
+                  <c:v>78.5</c:v>
                 </c:pt>
                 <c:pt idx="47">
-                  <c:v>93.6</c:v>
+                  <c:v>77.7</c:v>
                 </c:pt>
                 <c:pt idx="48">
-                  <c:v>93.2</c:v>
+                  <c:v>77</c:v>
                 </c:pt>
                 <c:pt idx="49">
-                  <c:v>92.8</c:v>
+                  <c:v>76.2</c:v>
                 </c:pt>
                 <c:pt idx="50">
-                  <c:v>96.6</c:v>
+                  <c:v>75.5</c:v>
                 </c:pt>
               </c:numCache>
             </c:numRef>
@@ -2142,82 +2142,82 @@
                   <c:v>108</c:v>
                 </c:pt>
                 <c:pt idx="25">
-                  <c:v>94.9</c:v>
+                  <c:v>105.2</c:v>
                 </c:pt>
                 <c:pt idx="26">
+                  <c:v>102.5</c:v>
+                </c:pt>
+                <c:pt idx="27">
+                  <c:v>99.9</c:v>
+                </c:pt>
+                <c:pt idx="28">
+                  <c:v>97.4</c:v>
+                </c:pt>
+                <c:pt idx="29">
+                  <c:v>95</c:v>
+                </c:pt>
+                <c:pt idx="30">
+                  <c:v>92.7</c:v>
+                </c:pt>
+                <c:pt idx="31">
                   <c:v>90.5</c:v>
                 </c:pt>
-                <c:pt idx="27">
-                  <c:v>86.5</c:v>
-                </c:pt>
-                <c:pt idx="28">
-                  <c:v>82.8</c:v>
-                </c:pt>
-                <c:pt idx="29">
-                  <c:v>79.4</c:v>
-                </c:pt>
-                <c:pt idx="30">
-                  <c:v>76.3</c:v>
-                </c:pt>
-                <c:pt idx="31">
-                  <c:v>73.5</c:v>
-                </c:pt>
                 <c:pt idx="32">
-                  <c:v>71</c:v>
+                  <c:v>88.4</c:v>
                 </c:pt>
                 <c:pt idx="33">
-                  <c:v>68.7</c:v>
+                  <c:v>86.4</c:v>
                 </c:pt>
                 <c:pt idx="34">
-                  <c:v>66.6</c:v>
+                  <c:v>84.5</c:v>
                 </c:pt>
                 <c:pt idx="35">
-                  <c:v>77.5</c:v>
+                  <c:v>80.2</c:v>
                 </c:pt>
                 <c:pt idx="36">
-                  <c:v>64.8</c:v>
+                  <c:v>78.6</c:v>
                 </c:pt>
                 <c:pt idx="37">
-                  <c:v>63.2</c:v>
+                  <c:v>77</c:v>
                 </c:pt>
                 <c:pt idx="38">
-                  <c:v>61.8</c:v>
+                  <c:v>75.5</c:v>
                 </c:pt>
                 <c:pt idx="39">
-                  <c:v>60.6</c:v>
+                  <c:v>74.1</c:v>
                 </c:pt>
                 <c:pt idx="40">
-                  <c:v>59.5</c:v>
+                  <c:v>72.8</c:v>
                 </c:pt>
                 <c:pt idx="41">
-                  <c:v>59.3</c:v>
+                  <c:v>71.5</c:v>
                 </c:pt>
                 <c:pt idx="42">
-                  <c:v>59.1</c:v>
+                  <c:v>70.3</c:v>
                 </c:pt>
                 <c:pt idx="43">
-                  <c:v>58.9</c:v>
+                  <c:v>69.2</c:v>
                 </c:pt>
                 <c:pt idx="44">
-                  <c:v>58.8</c:v>
+                  <c:v>68.1</c:v>
                 </c:pt>
                 <c:pt idx="45">
-                  <c:v>58.7</c:v>
+                  <c:v>67.1</c:v>
                 </c:pt>
                 <c:pt idx="46">
-                  <c:v>58.6</c:v>
+                  <c:v>66.1</c:v>
                 </c:pt>
                 <c:pt idx="47">
-                  <c:v>58.5</c:v>
+                  <c:v>65.2</c:v>
                 </c:pt>
                 <c:pt idx="48">
-                  <c:v>58.5</c:v>
+                  <c:v>64.4</c:v>
                 </c:pt>
                 <c:pt idx="49">
-                  <c:v>58.4</c:v>
+                  <c:v>63.6</c:v>
                 </c:pt>
                 <c:pt idx="50">
-                  <c:v>59.7</c:v>
+                  <c:v>57.4</c:v>
                 </c:pt>
               </c:numCache>
             </c:numRef>
@@ -2538,82 +2538,82 @@
                   <c:v>108</c:v>
                 </c:pt>
                 <c:pt idx="25">
-                  <c:v>141.3</c:v>
+                  <c:v>107.1</c:v>
                 </c:pt>
                 <c:pt idx="26">
-                  <c:v>139.5</c:v>
+                  <c:v>106</c:v>
                 </c:pt>
                 <c:pt idx="27">
-                  <c:v>137.8</c:v>
+                  <c:v>105</c:v>
                 </c:pt>
                 <c:pt idx="28">
-                  <c:v>136.2</c:v>
+                  <c:v>104</c:v>
                 </c:pt>
                 <c:pt idx="29">
-                  <c:v>134.6</c:v>
+                  <c:v>103</c:v>
                 </c:pt>
                 <c:pt idx="30">
-                  <c:v>133.1</c:v>
+                  <c:v>102.1</c:v>
                 </c:pt>
                 <c:pt idx="31">
-                  <c:v>131.7</c:v>
+                  <c:v>101.2</c:v>
                 </c:pt>
                 <c:pt idx="32">
-                  <c:v>130.4</c:v>
+                  <c:v>100.4</c:v>
                 </c:pt>
                 <c:pt idx="33">
-                  <c:v>129.1</c:v>
+                  <c:v>99.6</c:v>
                 </c:pt>
                 <c:pt idx="34">
-                  <c:v>127.9</c:v>
+                  <c:v>98.8</c:v>
                 </c:pt>
                 <c:pt idx="35">
-                  <c:v>132.2</c:v>
+                  <c:v>97.1</c:v>
                 </c:pt>
                 <c:pt idx="36">
-                  <c:v>126.7</c:v>
+                  <c:v>96.4</c:v>
                 </c:pt>
                 <c:pt idx="37">
-                  <c:v>125.6</c:v>
+                  <c:v>95.8</c:v>
                 </c:pt>
                 <c:pt idx="38">
-                  <c:v>124.6</c:v>
+                  <c:v>95.2</c:v>
                 </c:pt>
                 <c:pt idx="39">
-                  <c:v>123.6</c:v>
+                  <c:v>94.6</c:v>
                 </c:pt>
                 <c:pt idx="40">
-                  <c:v>122.7</c:v>
+                  <c:v>94.1</c:v>
                 </c:pt>
                 <c:pt idx="41">
-                  <c:v>122.4</c:v>
+                  <c:v>93.6</c:v>
                 </c:pt>
                 <c:pt idx="42">
-                  <c:v>122.1</c:v>
+                  <c:v>93.1</c:v>
                 </c:pt>
                 <c:pt idx="43">
-                  <c:v>121.8</c:v>
+                  <c:v>92.7</c:v>
                 </c:pt>
                 <c:pt idx="44">
-                  <c:v>121.5</c:v>
+                  <c:v>92.3</c:v>
                 </c:pt>
                 <c:pt idx="45">
-                  <c:v>121.3</c:v>
+                  <c:v>91.9</c:v>
                 </c:pt>
                 <c:pt idx="46">
-                  <c:v>121.1</c:v>
+                  <c:v>91.5</c:v>
                 </c:pt>
                 <c:pt idx="47">
-                  <c:v>120.9</c:v>
+                  <c:v>91.2</c:v>
                 </c:pt>
                 <c:pt idx="48">
-                  <c:v>120.8</c:v>
+                  <c:v>90.9</c:v>
                 </c:pt>
                 <c:pt idx="49">
-                  <c:v>120.6</c:v>
+                  <c:v>90.6</c:v>
                 </c:pt>
                 <c:pt idx="50">
-                  <c:v>120.9</c:v>
+                  <c:v>88.2</c:v>
                 </c:pt>
               </c:numCache>
             </c:numRef>
@@ -6144,7 +6144,7 @@
                 <a:ea typeface="Calibri" pitchFamily="34" charset="-122"/>
                 <a:cs typeface="Calibri" pitchFamily="34" charset="-120"/>
               </a:rPr>
-              <a:t>Alpine snowmelt feeds the Rhine, Danube, Po, and Rhone rivers. Projections show low-elevation snow dropping to ~97 days by 2050 (60 under RCP 8.5), threatening hydropower, agriculture, and municipal water.</a:t>
+              <a:t>Alpine snowmelt feeds the Rhine, Danube, Po, and Rhone rivers. Projections show low-elevation snow dropping to 76 days by 2050 (57 under RCP 8.5), threatening hydropower, agriculture, and municipal water.</a:t>
             </a:r>
             <a:endParaRPr lang="en-US" sz="1300" dirty="0"/>
           </a:p>
@@ -6253,7 +6253,7 @@
                 <a:ea typeface="Calibri" pitchFamily="34" charset="-122"/>
                 <a:cs typeface="Calibri" pitchFamily="34" charset="-120"/>
               </a:rPr>
-              <a:t>Low-elevation resorts (&lt;1500m) face ~3 months of snow by 2050 (97 days current, 60 under RCP 8.5). This helps the 70B+ euro ski industry make data-driven decisions about snowmaking and diversification.</a:t>
+              <a:t>Low-elevation resorts (&lt;1500m) face ~2.5 months of snow by 2050 (76 days current trend, 57 under RCP 8.5). This helps the 70B+ euro ski industry make data-driven decisions about snowmaking and diversification.</a:t>
             </a:r>
             <a:endParaRPr lang="en-US" sz="1300" dirty="0"/>
           </a:p>
@@ -10479,7 +10479,7 @@
                 <a:ea typeface="Georgia" pitchFamily="34" charset="-122"/>
                 <a:cs typeface="Georgia" pitchFamily="34" charset="-120"/>
               </a:rPr>
-              <a:t>97</a:t>
+              <a:t>76</a:t>
             </a:r>
             <a:endParaRPr lang="en-US" sz="5200" dirty="0"/>
           </a:p>
@@ -13370,7 +13370,7 @@
                           <a:ea typeface="Calibri" pitchFamily="34" charset="-122"/>
                           <a:cs typeface="Calibri" pitchFamily="34" charset="-120"/>
                         </a:rPr>
-                        <a:t>97 days</a:t>
+                        <a:t>76 days</a:t>
                       </a:r>
                       <a:endParaRPr lang="en-US" sz="1000" dirty="0">
                         <a:latin typeface="Calibri" charset="0"/>
@@ -13438,7 +13438,7 @@
                           <a:ea typeface="Calibri" pitchFamily="34" charset="-122"/>
                           <a:cs typeface="Calibri" pitchFamily="34" charset="-120"/>
                         </a:rPr>
-                        <a:t>-11 days</a:t>
+                        <a:t>-32 days</a:t>
                       </a:r>
                       <a:endParaRPr lang="en-US" sz="1000" dirty="0">
                         <a:latin typeface="Calibri" charset="0"/>
@@ -13576,7 +13576,7 @@
                           <a:ea typeface="Calibri" pitchFamily="34" charset="-122"/>
                           <a:cs typeface="Calibri" pitchFamily="34" charset="-120"/>
                         </a:rPr>
-                        <a:t>60 days</a:t>
+                        <a:t>57 days</a:t>
                       </a:r>
                       <a:endParaRPr lang="en-US" sz="1000" dirty="0">
                         <a:latin typeface="Calibri" charset="0"/>
@@ -13644,7 +13644,7 @@
                           <a:ea typeface="Calibri" pitchFamily="34" charset="-122"/>
                           <a:cs typeface="Calibri" pitchFamily="34" charset="-120"/>
                         </a:rPr>
-                        <a:t>-48 days</a:t>
+                        <a:t>-51 days</a:t>
                       </a:r>
                       <a:endParaRPr lang="en-US" sz="1000" dirty="0">
                         <a:latin typeface="Calibri" charset="0"/>
@@ -13782,7 +13782,7 @@
                           <a:ea typeface="Calibri" pitchFamily="34" charset="-122"/>
                           <a:cs typeface="Calibri" pitchFamily="34" charset="-120"/>
                         </a:rPr>
-                        <a:t>121 days</a:t>
+                        <a:t>88 days</a:t>
                       </a:r>
                       <a:endParaRPr lang="en-US" sz="1000" dirty="0">
                         <a:latin typeface="Calibri" charset="0"/>
@@ -13850,7 +13850,7 @@
                           <a:ea typeface="Calibri" pitchFamily="34" charset="-122"/>
                           <a:cs typeface="Calibri" pitchFamily="34" charset="-120"/>
                         </a:rPr>
-                        <a:t>-13 days</a:t>
+                        <a:t>-20 days</a:t>
                       </a:r>
                       <a:endParaRPr lang="en-US" sz="1000" dirty="0">
                         <a:latin typeface="Calibri" charset="0"/>
@@ -13942,7 +13942,7 @@
                 <a:ea typeface="Calibri" pitchFamily="34" charset="-122"/>
                 <a:cs typeface="Calibri" pitchFamily="34" charset="-120"/>
               </a:rPr>
-              <a:t>Under current trends, low-elevation Alps will have ~97 snow days by 2050 (just 3 months). RCP 8.5 drops it to 60 days — 2 months.</a:t>
+              <a:t>Under current trends, low-elevation Alps will have just 76 snow days by 2050 (~2.5 months). RCP 8.5 drops it to 57 days — under 2 months.</a:t>
             </a:r>
             <a:endParaRPr lang="en-US" sz="1100" dirty="0"/>
           </a:p>
@@ -13962,7 +13962,7 @@
                 <a:ea typeface="Calibri" pitchFamily="34" charset="-122"/>
                 <a:cs typeface="Calibri" pitchFamily="34" charset="-120"/>
               </a:rPr>
-              <a:t>Mid Alps remain stable at ~311 days. High Alps stay at 366 (year-round). The divergence between elevation bands will only widen.</a:t>
+              <a:t>Mid Alps converge toward ~312 days (mean reversion). High Alps stay at 366 (year-round). The divergence between bands widens.</a:t>
             </a:r>
             <a:endParaRPr lang="en-US" sz="1100" dirty="0"/>
           </a:p>
@@ -14000,7 +14000,7 @@
                 <a:ea typeface="Calibri" pitchFamily="34" charset="-122"/>
                 <a:cs typeface="Calibri" pitchFamily="34" charset="-120"/>
               </a:rPr>
-              <a:t>Exponential decay model: floor + (S0-floor)*exp(-r*t). Floor = 60 days (core winter retains snow). Physically motivated — decline slows as it approaches the climatological minimum.</a:t>
+              <a:t>Method: Exponential decay model — floor + (S_last - floor) × exp(-r × t). Decay rate r calibrated to match observed slope (-2.11 days/yr). Floor = 60 days (core winter retains snow even with warming). Physically motivated: decline slows as snow approaches climatological minimum.</a:t>
             </a:r>
             <a:endParaRPr lang="en-US" sz="1100" dirty="0"/>
           </a:p>
@@ -14039,7 +14039,7 @@
                 <a:ea typeface="Calibri" pitchFamily="34" charset="-122"/>
                 <a:cs typeface="Calibri" pitchFamily="34" charset="-120"/>
               </a:rPr>
-              <a:t>Data Source: ARIMA forecast on ERA5 data | statsmodels library | 3 IPCC scenario multipliers</a:t>
+              <a:t>Data Source: Exponential decay model on ERA5 data | scipy.optimize | Floor calibrated to core winter | IPCC scenario multipliers</a:t>
             </a:r>
             <a:endParaRPr lang="en-US" sz="900" dirty="0"/>
           </a:p>

</xml_diff>

<commit_message>
rename: AlpineVerify → SnowLens
</commit_message>
<xml_diff>
--- a/AIB_03_00_SLIDES_ASU.pptx
+++ b/AIB_03_00_SLIDES_ASU.pptx
@@ -4696,7 +4696,7 @@
                 <a:ea typeface="Georgia" pitchFamily="34" charset="-122"/>
                 <a:cs typeface="Georgia" pitchFamily="34" charset="-120"/>
               </a:rPr>
-              <a:t>AlpineVerify: Satellite Truth</a:t>
+              <a:t>SnowLens: Satellite Lens</a:t>
             </a:r>
             <a:endParaRPr lang="en-US" sz="4000" dirty="0"/>
           </a:p>
@@ -4716,7 +4716,7 @@
                 <a:ea typeface="Georgia" pitchFamily="34" charset="-122"/>
                 <a:cs typeface="Georgia" pitchFamily="34" charset="-120"/>
               </a:rPr>
-              <a:t>vs. Climate Fiction</a:t>
+              <a:t>on Alpine Snow</a:t>
             </a:r>
             <a:endParaRPr lang="en-US" sz="4000" dirty="0"/>
           </a:p>
@@ -5707,7 +5707,7 @@
                 <a:ea typeface="Calibri" pitchFamily="34" charset="-122"/>
                 <a:cs typeface="Calibri" pitchFamily="34" charset="-120"/>
               </a:rPr>
-              <a:t>AlpineVerify’s Fact Checker matches claims against real statistical results from our ERA5 analysis. Each verdict includes a confidence level from actual p-values, a plain-English explanation with specific numbers, and an evidence chart from real station data. No GIS expertise required — built for journalists, educators, and policymakers.</a:t>
+              <a:t>SnowLens’s Fact Checker matches claims against real statistical results from our ERA5 analysis. Each verdict includes a confidence level from actual p-values, a plain-English explanation with specific numbers, and an evidence chart from real station data. No GIS expertise required — built for journalists, educators, and policymakers.</a:t>
             </a:r>
             <a:endParaRPr lang="en-US" sz="1050" dirty="0"/>
           </a:p>
@@ -5926,7 +5926,7 @@
                 <a:ea typeface="Calibri" pitchFamily="34" charset="-122"/>
                 <a:cs typeface="Calibri" pitchFamily="34" charset="-120"/>
               </a:rPr>
-              <a:t>Climate reporters can verify any claim about Alpine snow in seconds. AlpineVerify provides citation-ready charts with source attribution — p-values, station names, methodology. Ready to embed in articles.</a:t>
+              <a:t>Climate reporters can verify any claim about Alpine snow in seconds. SnowLens provides citation-ready charts with source attribution — p-values, station names, methodology. Ready to embed in articles.</a:t>
             </a:r>
             <a:endParaRPr lang="en-US" sz="1300" dirty="0"/>
           </a:p>
@@ -6362,7 +6362,7 @@
                 <a:ea typeface="Calibri" pitchFamily="34" charset="-122"/>
                 <a:cs typeface="Calibri" pitchFamily="34" charset="-120"/>
               </a:rPr>
-              <a:t>ERA5 reanalysis is the only source providing consistent, gap-free, 25-year coverage across remote Alpine locations. AlpineVerify makes it accessible to everyone, not just climate scientists.</a:t>
+              <a:t>ERA5 reanalysis is the only source providing consistent, gap-free, 25-year coverage across remote Alpine locations. SnowLens makes it accessible to everyone, not just climate scientists.</a:t>
             </a:r>
             <a:endParaRPr lang="en-US" sz="1300" dirty="0"/>
           </a:p>
@@ -6433,7 +6433,7 @@
                 <a:ea typeface="Georgia" pitchFamily="34" charset="-122"/>
                 <a:cs typeface="Georgia" pitchFamily="34" charset="-120"/>
               </a:rPr>
-              <a:t>Where AlpineVerify Goes Next</a:t>
+              <a:t>Where SnowLens Goes Next</a:t>
             </a:r>
             <a:endParaRPr lang="en-US" sz="3800" dirty="0"/>
           </a:p>
@@ -7485,7 +7485,7 @@
                 <a:ea typeface="Calibri" pitchFamily="34" charset="-122"/>
                 <a:cs typeface="Calibri" pitchFamily="34" charset="-120"/>
               </a:rPr>
-              <a:t>github.com/Samudyata/AlpineVerify</a:t>
+              <a:t>github.com/Samudyata/SnowLens</a:t>
             </a:r>
             <a:endParaRPr lang="en-US" sz="1100" dirty="0"/>
           </a:p>
@@ -7634,7 +7634,7 @@
                 <a:ea typeface="Calibri" pitchFamily="34" charset="-122"/>
                 <a:cs typeface="Calibri" pitchFamily="34" charset="-120"/>
               </a:rPr>
-              <a:t>AlpineVerify — Making climate evidence accessible to everyone.</a:t>
+              <a:t>SnowLens — Making climate evidence accessible to everyone.</a:t>
             </a:r>
             <a:endParaRPr lang="en-US" sz="1600" dirty="0"/>
           </a:p>
@@ -7718,7 +7718,7 @@
                 <a:ea typeface="Calibri" pitchFamily="34" charset="-122"/>
                 <a:cs typeface="Calibri" pitchFamily="34" charset="-120"/>
               </a:rPr>
-              <a:t>github.com/Samudyata/AlpineVerify</a:t>
+              <a:t>github.com/Samudyata/SnowLens</a:t>
             </a:r>
             <a:endParaRPr lang="en-US" sz="1200" dirty="0"/>
           </a:p>

</xml_diff>